<commit_message>
feat: add Functions slides and update Collections and Loop presentation materials
</commit_message>
<xml_diff>
--- a/slides/07 - Collections Data Types.pptx
+++ b/slides/07 - Collections Data Types.pptx
@@ -26066,14 +26066,14 @@
             <a:r>
               <a:rPr b="1" lang="en" sz="2025">
                 <a:solidFill>
-                  <a:schemeClr val="accent2"/>
+                  <a:schemeClr val="accent4"/>
                 </a:solidFill>
               </a:rPr>
               <a:t>a single, basic value</a:t>
             </a:r>
             <a:endParaRPr b="1" sz="2700">
               <a:solidFill>
-                <a:schemeClr val="accent2"/>
+                <a:schemeClr val="accent4"/>
               </a:solidFill>
             </a:endParaRPr>
           </a:p>
@@ -26661,7 +26661,7 @@
                 <a:cs typeface="Roboto"/>
                 <a:sym typeface="Roboto"/>
               </a:rPr>
-              <a:t>, milk, edge</a:t>
+              <a:t>, milk, eggs</a:t>
             </a:r>
             <a:endParaRPr sz="1100">
               <a:solidFill>
@@ -27953,59 +27953,23 @@
                 <a:cs typeface="Roboto"/>
                 <a:sym typeface="Roboto"/>
               </a:rPr>
-              <a:t> </a:t>
+              <a:t> the </a:t>
             </a:r>
             <a:r>
               <a:rPr lang="en" sz="1000">
                 <a:solidFill>
-                  <a:srgbClr val="D84568"/>
+                  <a:schemeClr val="dk2"/>
                 </a:solidFill>
                 <a:latin typeface="Verdana"/>
                 <a:ea typeface="Verdana"/>
                 <a:cs typeface="Verdana"/>
                 <a:sym typeface="Verdana"/>
               </a:rPr>
-              <a:t>.keys()</a:t>
-            </a:r>
-            <a:r>
-              <a:rPr lang="en" sz="1100">
-                <a:solidFill>
-                  <a:srgbClr val="222540"/>
-                </a:solidFill>
-                <a:latin typeface="Roboto"/>
-                <a:ea typeface="Roboto"/>
-                <a:cs typeface="Roboto"/>
-                <a:sym typeface="Roboto"/>
-              </a:rPr>
-              <a:t> and </a:t>
-            </a:r>
-            <a:r>
-              <a:rPr lang="en" sz="1000">
-                <a:solidFill>
-                  <a:srgbClr val="D84568"/>
-                </a:solidFill>
-                <a:latin typeface="Verdana"/>
-                <a:ea typeface="Verdana"/>
-                <a:cs typeface="Verdana"/>
-                <a:sym typeface="Verdana"/>
-              </a:rPr>
-              <a:t>.values()</a:t>
-            </a:r>
-            <a:r>
-              <a:rPr lang="en" sz="1100">
-                <a:solidFill>
-                  <a:srgbClr val="222540"/>
-                </a:solidFill>
-                <a:latin typeface="Roboto"/>
-                <a:ea typeface="Roboto"/>
-                <a:cs typeface="Roboto"/>
-                <a:sym typeface="Roboto"/>
-              </a:rPr>
-              <a:t>.</a:t>
+              <a:t>dict again</a:t>
             </a:r>
             <a:endParaRPr sz="1100">
               <a:solidFill>
-                <a:srgbClr val="222540"/>
+                <a:schemeClr val="dk2"/>
               </a:solidFill>
               <a:latin typeface="Roboto"/>
               <a:ea typeface="Roboto"/>
@@ -28214,7 +28178,31 @@
                 <a:cs typeface="Verdana"/>
                 <a:sym typeface="Verdana"/>
               </a:rPr>
-              <a:t>	[4]  {'title': 'Dune', 'author': 'Frank Herbert', 'year': 2021}</a:t>
+              <a:t>	[4]  {'title': 'Dune', 'author': 'Frank Herbert', </a:t>
+            </a:r>
+            <a:r>
+              <a:rPr lang="en" sz="1000">
+                <a:solidFill>
+                  <a:srgbClr val="6B7085"/>
+                </a:solidFill>
+                <a:latin typeface="Verdana"/>
+                <a:ea typeface="Verdana"/>
+                <a:cs typeface="Verdana"/>
+                <a:sym typeface="Verdana"/>
+              </a:rPr>
+              <a:t> 'genre': 'Sci-Fi'</a:t>
+            </a:r>
+            <a:r>
+              <a:rPr lang="en" sz="1000">
+                <a:solidFill>
+                  <a:srgbClr val="6B7085"/>
+                </a:solidFill>
+                <a:latin typeface="Verdana"/>
+                <a:ea typeface="Verdana"/>
+                <a:cs typeface="Verdana"/>
+                <a:sym typeface="Verdana"/>
+              </a:rPr>
+              <a:t>}</a:t>
             </a:r>
             <a:endParaRPr sz="1000">
               <a:solidFill>
@@ -29933,6 +29921,37 @@
               <a:spcAft>
                 <a:spcPts val="0"/>
               </a:spcAft>
+              <a:buNone/>
+            </a:pPr>
+            <a:r>
+              <a:rPr lang="en"/>
+              <a:t>Practice - Basic Collection Methods</a:t>
+            </a:r>
+            <a:endParaRPr/>
+          </a:p>
+          <a:p>
+            <a:pPr indent="0" lvl="0" marL="0" rtl="0" algn="l">
+              <a:spcBef>
+                <a:spcPts val="0"/>
+              </a:spcBef>
+              <a:spcAft>
+                <a:spcPts val="0"/>
+              </a:spcAft>
+              <a:buNone/>
+            </a:pPr>
+            <a:r>
+              <a:t/>
+            </a:r>
+            <a:endParaRPr/>
+          </a:p>
+          <a:p>
+            <a:pPr indent="0" lvl="0" marL="0" rtl="0" algn="l">
+              <a:spcBef>
+                <a:spcPts val="0"/>
+              </a:spcBef>
+              <a:spcAft>
+                <a:spcPts val="0"/>
+              </a:spcAft>
               <a:buClr>
                 <a:srgbClr val="293480"/>
               </a:buClr>
@@ -29941,16 +29960,7 @@
               <a:buNone/>
             </a:pPr>
             <a:r>
-              <a:rPr b="1" lang="en" sz="2100">
-                <a:solidFill>
-                  <a:srgbClr val="293480"/>
-                </a:solidFill>
-                <a:latin typeface="Roboto"/>
-                <a:ea typeface="Roboto"/>
-                <a:cs typeface="Roboto"/>
-                <a:sym typeface="Roboto"/>
-              </a:rPr>
-              <a:t>Grocery List Basics  &amp;  Reversing &amp; Sorting</a:t>
+              <a:t/>
             </a:r>
             <a:endParaRPr/>
           </a:p>
@@ -31490,6 +31500,37 @@
               <a:spcAft>
                 <a:spcPts val="0"/>
               </a:spcAft>
+              <a:buNone/>
+            </a:pPr>
+            <a:r>
+              <a:rPr lang="en"/>
+              <a:t>Practice - Basic Collection Methods</a:t>
+            </a:r>
+            <a:endParaRPr/>
+          </a:p>
+          <a:p>
+            <a:pPr indent="0" lvl="0" marL="0" rtl="0" algn="l">
+              <a:spcBef>
+                <a:spcPts val="0"/>
+              </a:spcBef>
+              <a:spcAft>
+                <a:spcPts val="0"/>
+              </a:spcAft>
+              <a:buNone/>
+            </a:pPr>
+            <a:r>
+              <a:t/>
+            </a:r>
+            <a:endParaRPr/>
+          </a:p>
+          <a:p>
+            <a:pPr indent="0" lvl="0" marL="0" rtl="0" algn="l">
+              <a:spcBef>
+                <a:spcPts val="0"/>
+              </a:spcBef>
+              <a:spcAft>
+                <a:spcPts val="0"/>
+              </a:spcAft>
               <a:buClr>
                 <a:srgbClr val="293480"/>
               </a:buClr>
@@ -31498,16 +31539,7 @@
               <a:buNone/>
             </a:pPr>
             <a:r>
-              <a:rPr b="1" lang="en" sz="2100">
-                <a:solidFill>
-                  <a:srgbClr val="293480"/>
-                </a:solidFill>
-                <a:latin typeface="Roboto"/>
-                <a:ea typeface="Roboto"/>
-                <a:cs typeface="Roboto"/>
-                <a:sym typeface="Roboto"/>
-              </a:rPr>
-              <a:t>Movie Tracker  &amp;  Coordinate Unpacking</a:t>
+              <a:t/>
             </a:r>
             <a:endParaRPr/>
           </a:p>
@@ -33059,6 +33091,37 @@
               <a:spcAft>
                 <a:spcPts val="0"/>
               </a:spcAft>
+              <a:buNone/>
+            </a:pPr>
+            <a:r>
+              <a:rPr lang="en"/>
+              <a:t>Practice - Basic Collection Methods</a:t>
+            </a:r>
+            <a:endParaRPr/>
+          </a:p>
+          <a:p>
+            <a:pPr indent="0" lvl="0" marL="0" rtl="0" algn="l">
+              <a:spcBef>
+                <a:spcPts val="0"/>
+              </a:spcBef>
+              <a:spcAft>
+                <a:spcPts val="0"/>
+              </a:spcAft>
+              <a:buNone/>
+            </a:pPr>
+            <a:r>
+              <a:t/>
+            </a:r>
+            <a:endParaRPr/>
+          </a:p>
+          <a:p>
+            <a:pPr indent="0" lvl="0" marL="0" rtl="0" algn="l">
+              <a:spcBef>
+                <a:spcPts val="0"/>
+              </a:spcBef>
+              <a:spcAft>
+                <a:spcPts val="0"/>
+              </a:spcAft>
               <a:buClr>
                 <a:srgbClr val="293480"/>
               </a:buClr>
@@ -33067,16 +33130,7 @@
               <a:buNone/>
             </a:pPr>
             <a:r>
-              <a:rPr b="1" lang="en" sz="2100">
-                <a:solidFill>
-                  <a:srgbClr val="293480"/>
-                </a:solidFill>
-                <a:latin typeface="Roboto"/>
-                <a:ea typeface="Roboto"/>
-                <a:cs typeface="Roboto"/>
-                <a:sym typeface="Roboto"/>
-              </a:rPr>
-              <a:t>Student Profile  &amp;  Updating Prices</a:t>
+              <a:t/>
             </a:r>
             <a:endParaRPr/>
           </a:p>
@@ -34865,6 +34919,37 @@
               <a:spcAft>
                 <a:spcPts val="0"/>
               </a:spcAft>
+              <a:buNone/>
+            </a:pPr>
+            <a:r>
+              <a:rPr lang="en"/>
+              <a:t>Practice - Basic Collection Methods</a:t>
+            </a:r>
+            <a:endParaRPr/>
+          </a:p>
+          <a:p>
+            <a:pPr indent="0" lvl="0" marL="0" rtl="0" algn="l">
+              <a:spcBef>
+                <a:spcPts val="0"/>
+              </a:spcBef>
+              <a:spcAft>
+                <a:spcPts val="0"/>
+              </a:spcAft>
+              <a:buNone/>
+            </a:pPr>
+            <a:r>
+              <a:t/>
+            </a:r>
+            <a:endParaRPr/>
+          </a:p>
+          <a:p>
+            <a:pPr indent="0" lvl="0" marL="0" rtl="0" algn="l">
+              <a:spcBef>
+                <a:spcPts val="0"/>
+              </a:spcBef>
+              <a:spcAft>
+                <a:spcPts val="0"/>
+              </a:spcAft>
               <a:buClr>
                 <a:srgbClr val="293480"/>
               </a:buClr>
@@ -34873,16 +34958,7 @@
               <a:buNone/>
             </a:pPr>
             <a:r>
-              <a:rPr b="1" lang="en" sz="2100">
-                <a:solidFill>
-                  <a:srgbClr val="293480"/>
-                </a:solidFill>
-                <a:latin typeface="Roboto"/>
-                <a:ea typeface="Roboto"/>
-                <a:cs typeface="Roboto"/>
-                <a:sym typeface="Roboto"/>
-              </a:rPr>
-              <a:t>Favorite Colors  &amp;  Club Membership</a:t>
+              <a:t/>
             </a:r>
             <a:endParaRPr/>
           </a:p>

</xml_diff>